<commit_message>
chore: structuring api for insights automation
</commit_message>
<xml_diff>
--- a/insights.pptx
+++ b/insights.pptx
@@ -5296,7 +5296,7 @@
                 <a:gridCol w="2377440"/>
                 <a:gridCol w="2377440"/>
               </a:tblGrid>
-              <a:tr h="285750">
+              <a:tr h="254000">
                 <a:tc>
                   <a:txBody>
                     <a:bodyPr/>
@@ -5310,7 +5310,7 @@
                         </a:defRPr>
                       </a:pPr>
                       <a:r>
-                        <a:t>Supply Period</a:t>
+                        <a:t>supply_period</a:t>
                       </a:r>
                     </a:p>
                   </a:txBody>
@@ -5413,7 +5413,7 @@
                   </a:tcPr>
                 </a:tc>
               </a:tr>
-              <a:tr h="285750">
+              <a:tr h="254000">
                 <a:tc>
                   <a:txBody>
                     <a:bodyPr/>
@@ -5423,7 +5423,7 @@
                         <a:defRPr sz="1000"/>
                       </a:pPr>
                       <a:r>
-                        <a:t>2023-11-30</a:t>
+                        <a:t>30/09/2023 0:00</a:t>
                       </a:r>
                     </a:p>
                   </a:txBody>
@@ -5453,7 +5453,7 @@
                         <a:defRPr sz="1000"/>
                       </a:pPr>
                       <a:r>
-                        <a:t>371,827.20</a:t>
+                        <a:t>348,110.04</a:t>
                       </a:r>
                     </a:p>
                   </a:txBody>
@@ -5468,7 +5468,7 @@
                         <a:defRPr sz="1000"/>
                       </a:pPr>
                       <a:r>
-                        <a:t>680.40</a:t>
+                        <a:t>629.85</a:t>
                       </a:r>
                     </a:p>
                   </a:txBody>
@@ -5483,14 +5483,14 @@
                         <a:defRPr sz="1000"/>
                       </a:pPr>
                       <a:r>
-                        <a:t>73.45%</a:t>
+                        <a:t>74.29%</a:t>
                       </a:r>
                     </a:p>
                   </a:txBody>
                   <a:tcPr/>
                 </a:tc>
               </a:tr>
-              <a:tr h="285750">
+              <a:tr h="254000">
                 <a:tc>
                   <a:txBody>
                     <a:bodyPr/>
@@ -5500,7 +5500,7 @@
                         <a:defRPr sz="1000"/>
                       </a:pPr>
                       <a:r>
-                        <a:t>2023-12-31</a:t>
+                        <a:t>31/10/2023 0:00</a:t>
                       </a:r>
                     </a:p>
                   </a:txBody>
@@ -5530,7 +5530,7 @@
                         <a:defRPr sz="1000"/>
                       </a:pPr>
                       <a:r>
-                        <a:t>370,132.62</a:t>
+                        <a:t>354,161.26</a:t>
                       </a:r>
                     </a:p>
                   </a:txBody>
@@ -5545,7 +5545,7 @@
                         <a:defRPr sz="1000"/>
                       </a:pPr>
                       <a:r>
-                        <a:t>709.92</a:t>
+                        <a:t>630.88</a:t>
                       </a:r>
                     </a:p>
                   </a:txBody>
@@ -5560,14 +5560,14 @@
                         <a:defRPr sz="1000"/>
                       </a:pPr>
                       <a:r>
-                        <a:t>72.41%</a:t>
+                        <a:t>77.97%</a:t>
                       </a:r>
                     </a:p>
                   </a:txBody>
                   <a:tcPr/>
                 </a:tc>
               </a:tr>
-              <a:tr h="285750">
+              <a:tr h="254000">
                 <a:tc>
                   <a:txBody>
                     <a:bodyPr/>
@@ -5577,7 +5577,7 @@
                         <a:defRPr sz="1000"/>
                       </a:pPr>
                       <a:r>
-                        <a:t>2024-01-31</a:t>
+                        <a:t>30/11/2023 0:00</a:t>
                       </a:r>
                     </a:p>
                   </a:txBody>
@@ -5607,7 +5607,7 @@
                         <a:defRPr sz="1000"/>
                       </a:pPr>
                       <a:r>
-                        <a:t>373,162.26</a:t>
+                        <a:t>366,267.71</a:t>
                       </a:r>
                     </a:p>
                   </a:txBody>
@@ -5622,7 +5622,7 @@
                         <a:defRPr sz="1000"/>
                       </a:pPr>
                       <a:r>
-                        <a:t>761.28</a:t>
+                        <a:t>639.44</a:t>
                       </a:r>
                     </a:p>
                   </a:txBody>
@@ -5637,14 +5637,14 @@
                         <a:defRPr sz="1000"/>
                       </a:pPr>
                       <a:r>
-                        <a:t>65.88%</a:t>
+                        <a:t>76.99%</a:t>
                       </a:r>
                     </a:p>
                   </a:txBody>
                   <a:tcPr/>
                 </a:tc>
               </a:tr>
-              <a:tr h="285750">
+              <a:tr h="254000">
                 <a:tc>
                   <a:txBody>
                     <a:bodyPr/>
@@ -5654,7 +5654,7 @@
                         <a:defRPr sz="1000"/>
                       </a:pPr>
                       <a:r>
-                        <a:t>2024-02-29</a:t>
+                        <a:t>31/12/2023 0:00</a:t>
                       </a:r>
                     </a:p>
                   </a:txBody>
@@ -5669,6 +5669,83 @@
                         <a:defRPr sz="1000"/>
                       </a:pPr>
                       <a:r>
+                        <a:t>720.00</a:t>
+                      </a:r>
+                    </a:p>
+                  </a:txBody>
+                  <a:tcPr/>
+                </a:tc>
+                <a:tc>
+                  <a:txBody>
+                    <a:bodyPr/>
+                    <a:lstStyle/>
+                    <a:p>
+                      <a:pPr algn="ctr">
+                        <a:defRPr sz="1000"/>
+                      </a:pPr>
+                      <a:r>
+                        <a:t>356,928.48</a:t>
+                      </a:r>
+                    </a:p>
+                  </a:txBody>
+                  <a:tcPr/>
+                </a:tc>
+                <a:tc>
+                  <a:txBody>
+                    <a:bodyPr/>
+                    <a:lstStyle/>
+                    <a:p>
+                      <a:pPr algn="ctr">
+                        <a:defRPr sz="1000"/>
+                      </a:pPr>
+                      <a:r>
+                        <a:t>653.81</a:t>
+                      </a:r>
+                    </a:p>
+                  </a:txBody>
+                  <a:tcPr/>
+                </a:tc>
+                <a:tc>
+                  <a:txBody>
+                    <a:bodyPr/>
+                    <a:lstStyle/>
+                    <a:p>
+                      <a:pPr algn="ctr">
+                        <a:defRPr sz="1000"/>
+                      </a:pPr>
+                      <a:r>
+                        <a:t>75.82%</a:t>
+                      </a:r>
+                    </a:p>
+                  </a:txBody>
+                  <a:tcPr/>
+                </a:tc>
+              </a:tr>
+              <a:tr h="254000">
+                <a:tc>
+                  <a:txBody>
+                    <a:bodyPr/>
+                    <a:lstStyle/>
+                    <a:p>
+                      <a:pPr algn="ctr">
+                        <a:defRPr sz="1000"/>
+                      </a:pPr>
+                      <a:r>
+                        <a:t>31/01/2024 0:00</a:t>
+                      </a:r>
+                    </a:p>
+                  </a:txBody>
+                  <a:tcPr/>
+                </a:tc>
+                <a:tc>
+                  <a:txBody>
+                    <a:bodyPr/>
+                    <a:lstStyle/>
+                    <a:p>
+                      <a:pPr algn="ctr">
+                        <a:defRPr sz="1000"/>
+                      </a:pPr>
+                      <a:r>
                         <a:t>744.00</a:t>
                       </a:r>
                     </a:p>
@@ -5684,7 +5761,7 @@
                         <a:defRPr sz="1000"/>
                       </a:pPr>
                       <a:r>
-                        <a:t>404,063.91</a:t>
+                        <a:t>327,379.59</a:t>
                       </a:r>
                     </a:p>
                   </a:txBody>
@@ -5699,7 +5776,7 @@
                         <a:defRPr sz="1000"/>
                       </a:pPr>
                       <a:r>
-                        <a:t>717.84</a:t>
+                        <a:t>642.90</a:t>
                       </a:r>
                     </a:p>
                   </a:txBody>
@@ -5714,14 +5791,14 @@
                         <a:defRPr sz="1000"/>
                       </a:pPr>
                       <a:r>
-                        <a:t>75.66%</a:t>
+                        <a:t>68.44%</a:t>
                       </a:r>
                     </a:p>
                   </a:txBody>
                   <a:tcPr/>
                 </a:tc>
               </a:tr>
-              <a:tr h="285750">
+              <a:tr h="254000">
                 <a:tc>
                   <a:txBody>
                     <a:bodyPr/>
@@ -5731,7 +5808,7 @@
                         <a:defRPr sz="1000"/>
                       </a:pPr>
                       <a:r>
-                        <a:t>2024-03-31</a:t>
+                        <a:t>29/02/2024 0:00</a:t>
                       </a:r>
                     </a:p>
                   </a:txBody>
@@ -5746,6 +5823,83 @@
                         <a:defRPr sz="1000"/>
                       </a:pPr>
                       <a:r>
+                        <a:t>744.00</a:t>
+                      </a:r>
+                    </a:p>
+                  </a:txBody>
+                  <a:tcPr/>
+                </a:tc>
+                <a:tc>
+                  <a:txBody>
+                    <a:bodyPr/>
+                    <a:lstStyle/>
+                    <a:p>
+                      <a:pPr algn="ctr">
+                        <a:defRPr sz="1000"/>
+                      </a:pPr>
+                      <a:r>
+                        <a:t>305,358.59</a:t>
+                      </a:r>
+                    </a:p>
+                  </a:txBody>
+                  <a:tcPr/>
+                </a:tc>
+                <a:tc>
+                  <a:txBody>
+                    <a:bodyPr/>
+                    <a:lstStyle/>
+                    <a:p>
+                      <a:pPr algn="ctr">
+                        <a:defRPr sz="1000"/>
+                      </a:pPr>
+                      <a:r>
+                        <a:t>618.89</a:t>
+                      </a:r>
+                    </a:p>
+                  </a:txBody>
+                  <a:tcPr/>
+                </a:tc>
+                <a:tc>
+                  <a:txBody>
+                    <a:bodyPr/>
+                    <a:lstStyle/>
+                    <a:p>
+                      <a:pPr algn="ctr">
+                        <a:defRPr sz="1000"/>
+                      </a:pPr>
+                      <a:r>
+                        <a:t>66.32%</a:t>
+                      </a:r>
+                    </a:p>
+                  </a:txBody>
+                  <a:tcPr/>
+                </a:tc>
+              </a:tr>
+              <a:tr h="254000">
+                <a:tc>
+                  <a:txBody>
+                    <a:bodyPr/>
+                    <a:lstStyle/>
+                    <a:p>
+                      <a:pPr algn="ctr">
+                        <a:defRPr sz="1000"/>
+                      </a:pPr>
+                      <a:r>
+                        <a:t>31/03/2024 0:00</a:t>
+                      </a:r>
+                    </a:p>
+                  </a:txBody>
+                  <a:tcPr/>
+                </a:tc>
+                <a:tc>
+                  <a:txBody>
+                    <a:bodyPr/>
+                    <a:lstStyle/>
+                    <a:p>
+                      <a:pPr algn="ctr">
+                        <a:defRPr sz="1000"/>
+                      </a:pPr>
+                      <a:r>
                         <a:t>696.00</a:t>
                       </a:r>
                     </a:p>
@@ -5761,7 +5915,7 @@
                         <a:defRPr sz="1000"/>
                       </a:pPr>
                       <a:r>
-                        <a:t>380,537.25</a:t>
+                        <a:t>308,597.28</a:t>
                       </a:r>
                     </a:p>
                   </a:txBody>
@@ -5776,7 +5930,7 @@
                         <a:defRPr sz="1000"/>
                       </a:pPr>
                       <a:r>
-                        <a:t>648.24</a:t>
+                        <a:t>617.79</a:t>
                       </a:r>
                     </a:p>
                   </a:txBody>
@@ -5791,14 +5945,14 @@
                         <a:defRPr sz="1000"/>
                       </a:pPr>
                       <a:r>
-                        <a:t>84.34%</a:t>
+                        <a:t>71.77%</a:t>
                       </a:r>
                     </a:p>
                   </a:txBody>
                   <a:tcPr/>
                 </a:tc>
               </a:tr>
-              <a:tr h="285750">
+              <a:tr h="254000">
                 <a:tc>
                   <a:txBody>
                     <a:bodyPr/>
@@ -5808,7 +5962,7 @@
                         <a:defRPr sz="1000"/>
                       </a:pPr>
                       <a:r>
-                        <a:t>2024-04-30</a:t>
+                        <a:t>30/04/2024 0:00</a:t>
                       </a:r>
                     </a:p>
                   </a:txBody>
@@ -5838,7 +5992,7 @@
                         <a:defRPr sz="1000"/>
                       </a:pPr>
                       <a:r>
-                        <a:t>366,739.35</a:t>
+                        <a:t>362,519.50</a:t>
                       </a:r>
                     </a:p>
                   </a:txBody>
@@ -5853,7 +6007,7 @@
                         <a:defRPr sz="1000"/>
                       </a:pPr>
                       <a:r>
-                        <a:t>695.40</a:t>
+                        <a:t>631.87</a:t>
                       </a:r>
                     </a:p>
                   </a:txBody>
@@ -5868,14 +6022,14 @@
                         <a:defRPr sz="1000"/>
                       </a:pPr>
                       <a:r>
-                        <a:t>70.88%</a:t>
+                        <a:t>77.11%</a:t>
                       </a:r>
                     </a:p>
                   </a:txBody>
                   <a:tcPr/>
                 </a:tc>
               </a:tr>
-              <a:tr h="285750">
+              <a:tr h="254000">
                 <a:tc>
                   <a:txBody>
                     <a:bodyPr/>
@@ -5885,7 +6039,7 @@
                         <a:defRPr sz="1000"/>
                       </a:pPr>
                       <a:r>
-                        <a:t>2024-05-31</a:t>
+                        <a:t>31/05/2024 0:00</a:t>
                       </a:r>
                     </a:p>
                   </a:txBody>
@@ -5915,7 +6069,7 @@
                         <a:defRPr sz="1000"/>
                       </a:pPr>
                       <a:r>
-                        <a:t>366,741.18</a:t>
+                        <a:t>387,648.97</a:t>
                       </a:r>
                     </a:p>
                   </a:txBody>
@@ -5930,7 +6084,7 @@
                         <a:defRPr sz="1000"/>
                       </a:pPr>
                       <a:r>
-                        <a:t>645.00</a:t>
+                        <a:t>655.35</a:t>
                       </a:r>
                     </a:p>
                   </a:txBody>
@@ -5945,14 +6099,14 @@
                         <a:defRPr sz="1000"/>
                       </a:pPr>
                       <a:r>
-                        <a:t>78.97%</a:t>
+                        <a:t>82.15%</a:t>
                       </a:r>
                     </a:p>
                   </a:txBody>
                   <a:tcPr/>
                 </a:tc>
               </a:tr>
-              <a:tr h="285750">
+              <a:tr h="254000">
                 <a:tc>
                   <a:txBody>
                     <a:bodyPr/>
@@ -5962,7 +6116,7 @@
                         <a:defRPr sz="1000"/>
                       </a:pPr>
                       <a:r>
-                        <a:t>2024-06-30</a:t>
+                        <a:t>30/06/2024 0:00</a:t>
                       </a:r>
                     </a:p>
                   </a:txBody>
@@ -5992,7 +6146,7 @@
                         <a:defRPr sz="1000"/>
                       </a:pPr>
                       <a:r>
-                        <a:t>396,093.75</a:t>
+                        <a:t>340,091.73</a:t>
                       </a:r>
                     </a:p>
                   </a:txBody>
@@ -6007,7 +6161,7 @@
                         <a:defRPr sz="1000"/>
                       </a:pPr>
                       <a:r>
-                        <a:t>629.28</a:t>
+                        <a:t>586.11</a:t>
                       </a:r>
                     </a:p>
                   </a:txBody>
@@ -6022,14 +6176,14 @@
                         <a:defRPr sz="1000"/>
                       </a:pPr>
                       <a:r>
-                        <a:t>84.60%</a:t>
+                        <a:t>77.99%</a:t>
                       </a:r>
                     </a:p>
                   </a:txBody>
                   <a:tcPr/>
                 </a:tc>
               </a:tr>
-              <a:tr h="285750">
+              <a:tr h="254000">
                 <a:tc>
                   <a:txBody>
                     <a:bodyPr/>
@@ -6039,7 +6193,7 @@
                         <a:defRPr sz="1000"/>
                       </a:pPr>
                       <a:r>
-                        <a:t>2024-07-31</a:t>
+                        <a:t>31/07/2024 0:00</a:t>
                       </a:r>
                     </a:p>
                   </a:txBody>
@@ -6069,7 +6223,7 @@
                         <a:defRPr sz="1000"/>
                       </a:pPr>
                       <a:r>
-                        <a:t>359,701.77</a:t>
+                        <a:t>324,546.31</a:t>
                       </a:r>
                     </a:p>
                   </a:txBody>
@@ -6084,7 +6238,7 @@
                         <a:defRPr sz="1000"/>
                       </a:pPr>
                       <a:r>
-                        <a:t>654.12</a:t>
+                        <a:t>599.88</a:t>
                       </a:r>
                     </a:p>
                   </a:txBody>
@@ -6099,14 +6253,14 @@
                         <a:defRPr sz="1000"/>
                       </a:pPr>
                       <a:r>
-                        <a:t>76.38%</a:t>
+                        <a:t>75.14%</a:t>
                       </a:r>
                     </a:p>
                   </a:txBody>
                   <a:tcPr/>
                 </a:tc>
               </a:tr>
-              <a:tr h="285750">
+              <a:tr h="254000">
                 <a:tc>
                   <a:txBody>
                     <a:bodyPr/>
@@ -6116,7 +6270,7 @@
                         <a:defRPr sz="1000"/>
                       </a:pPr>
                       <a:r>
-                        <a:t>2024-08-31</a:t>
+                        <a:t>31/08/2024 0:00</a:t>
                       </a:r>
                     </a:p>
                   </a:txBody>
@@ -6146,7 +6300,7 @@
                         <a:defRPr sz="1000"/>
                       </a:pPr>
                       <a:r>
-                        <a:t>343,199.40</a:t>
+                        <a:t>324,362.94</a:t>
                       </a:r>
                     </a:p>
                   </a:txBody>
@@ -6161,7 +6315,7 @@
                         <a:defRPr sz="1000"/>
                       </a:pPr>
                       <a:r>
-                        <a:t>619.80</a:t>
+                        <a:t>642.68</a:t>
                       </a:r>
                     </a:p>
                   </a:txBody>
@@ -6176,14 +6330,14 @@
                         <a:defRPr sz="1000"/>
                       </a:pPr>
                       <a:r>
-                        <a:t>74.43%</a:t>
+                        <a:t>67.84%</a:t>
                       </a:r>
                     </a:p>
                   </a:txBody>
                   <a:tcPr/>
                 </a:tc>
               </a:tr>
-              <a:tr h="285750">
+              <a:tr h="254000">
                 <a:tc>
                   <a:txBody>
                     <a:bodyPr/>
@@ -6193,7 +6347,7 @@
                         <a:defRPr sz="1000"/>
                       </a:pPr>
                       <a:r>
-                        <a:t>2024-09-30</a:t>
+                        <a:t>30/09/2024 0:00</a:t>
                       </a:r>
                     </a:p>
                   </a:txBody>
@@ -6223,7 +6377,7 @@
                         <a:defRPr sz="1000"/>
                       </a:pPr>
                       <a:r>
-                        <a:t>355,670.31</a:t>
+                        <a:t>351,124.56</a:t>
                       </a:r>
                     </a:p>
                   </a:txBody>
@@ -6238,7 +6392,7 @@
                         <a:defRPr sz="1000"/>
                       </a:pPr>
                       <a:r>
-                        <a:t>633.24</a:t>
+                        <a:t>654.84</a:t>
                       </a:r>
                     </a:p>
                   </a:txBody>
@@ -6253,14 +6407,14 @@
                         <a:defRPr sz="1000"/>
                       </a:pPr>
                       <a:r>
-                        <a:t>75.49%</a:t>
+                        <a:t>72.07%</a:t>
                       </a:r>
                     </a:p>
                   </a:txBody>
                   <a:tcPr/>
                 </a:tc>
               </a:tr>
-              <a:tr h="285750">
+              <a:tr h="254000">
                 <a:tc>
                   <a:txBody>
                     <a:bodyPr/>
@@ -6285,7 +6439,7 @@
                         <a:defRPr sz="1000" b="1"/>
                       </a:pPr>
                       <a:r>
-                        <a:t>8,064.00</a:t>
+                        <a:t>9,528.00</a:t>
                       </a:r>
                     </a:p>
                   </a:txBody>
@@ -6300,7 +6454,7 @@
                         <a:defRPr sz="1000" b="1"/>
                       </a:pPr>
                       <a:r>
-                        <a:t>4,087,869.00</a:t>
+                        <a:t>4,457,096.96</a:t>
                       </a:r>
                     </a:p>
                   </a:txBody>
@@ -6315,7 +6469,7 @@
                         <a:defRPr sz="1000" b="1"/>
                       </a:pPr>
                       <a:r>
-                        <a:t>761.28</a:t>
+                        <a:t>655.35</a:t>
                       </a:r>
                     </a:p>
                   </a:txBody>
@@ -6330,14 +6484,14 @@
                         <a:defRPr sz="1000" b="1"/>
                       </a:pPr>
                       <a:r>
-                        <a:t>66.59%</a:t>
+                        <a:t>71.38%</a:t>
                       </a:r>
                     </a:p>
                   </a:txBody>
                   <a:tcPr/>
                 </a:tc>
               </a:tr>
-              <a:tr h="285750">
+              <a:tr h="254000">
                 <a:tc>
                   <a:txBody>
                     <a:bodyPr/>
@@ -6362,7 +6516,7 @@
                         <a:defRPr sz="1000" b="1"/>
                       </a:pPr>
                       <a:r>
-                        <a:t>733.09</a:t>
+                        <a:t>732.92</a:t>
                       </a:r>
                     </a:p>
                   </a:txBody>
@@ -6377,7 +6531,7 @@
                         <a:defRPr sz="1000" b="1"/>
                       </a:pPr>
                       <a:r>
-                        <a:t>371,624.45</a:t>
+                        <a:t>342,853.61</a:t>
                       </a:r>
                     </a:p>
                   </a:txBody>
@@ -6392,7 +6546,7 @@
                         <a:defRPr sz="1000" b="1"/>
                       </a:pPr>
                       <a:r>
-                        <a:t>672.23</a:t>
+                        <a:t>631.10</a:t>
                       </a:r>
                     </a:p>
                   </a:txBody>
@@ -6407,14 +6561,14 @@
                         <a:defRPr sz="1000" b="1"/>
                       </a:pPr>
                       <a:r>
-                        <a:t>75.68%</a:t>
+                        <a:t>74.15%</a:t>
                       </a:r>
                     </a:p>
                   </a:txBody>
                   <a:tcPr/>
                 </a:tc>
               </a:tr>
-              <a:tr h="285750">
+              <a:tr h="254000">
                 <a:tc>
                   <a:txBody>
                     <a:bodyPr/>
@@ -6454,7 +6608,7 @@
                         <a:defRPr sz="1000" b="1"/>
                       </a:pPr>
                       <a:r>
-                        <a:t>404,063.91</a:t>
+                        <a:t>387,648.97</a:t>
                       </a:r>
                     </a:p>
                   </a:txBody>
@@ -6469,7 +6623,7 @@
                         <a:defRPr sz="1000" b="1"/>
                       </a:pPr>
                       <a:r>
-                        <a:t>761.28</a:t>
+                        <a:t>655.35</a:t>
                       </a:r>
                     </a:p>
                   </a:txBody>
@@ -6484,14 +6638,14 @@
                         <a:defRPr sz="1000" b="1"/>
                       </a:pPr>
                       <a:r>
-                        <a:t>84.60%</a:t>
+                        <a:t>82.15%</a:t>
                       </a:r>
                     </a:p>
                   </a:txBody>
                   <a:tcPr/>
                 </a:tc>
               </a:tr>
-              <a:tr h="285750">
+              <a:tr h="254000">
                 <a:tc>
                   <a:txBody>
                     <a:bodyPr/>
@@ -6531,7 +6685,7 @@
                         <a:defRPr sz="1000" b="1"/>
                       </a:pPr>
                       <a:r>
-                        <a:t>343,199.40</a:t>
+                        <a:t>305,358.59</a:t>
                       </a:r>
                     </a:p>
                   </a:txBody>
@@ -6546,7 +6700,7 @@
                         <a:defRPr sz="1000" b="1"/>
                       </a:pPr>
                       <a:r>
-                        <a:t>619.80</a:t>
+                        <a:t>586.11</a:t>
                       </a:r>
                     </a:p>
                   </a:txBody>
@@ -6561,7 +6715,7 @@
                         <a:defRPr sz="1000" b="1"/>
                       </a:pPr>
                       <a:r>
-                        <a:t>65.88%</a:t>
+                        <a:t>66.32%</a:t>
                       </a:r>
                     </a:p>
                   </a:txBody>
@@ -6894,7 +7048,7 @@
       </p:sp>
       <p:pic>
         <p:nvPicPr>
-          <p:cNvPr id="4" name="Picture 3" descr="peak_demand_plot.png"/>
+          <p:cNvPr id="4" name="Picture 3" descr="daily_kw_report.png"/>
           <p:cNvPicPr>
             <a:picLocks noChangeAspect="1"/>
           </p:cNvPicPr>

</xml_diff>